<commit_message>
Add presentation materials and scripts for CIFAR-10 image classification project
- Updated PowerPoint presentation with 14 slides detailing project overview, system architecture, and performance metrics.
- Added individual markdown scripts for team members covering their respective topics:
  - A: Introduction, team roles, project background, and system design.
  - B: Data organization, model architecture, and training process.
  - C: Evaluation results, confusion matrix analysis, and robustness testing.
  - D: Inference performance and user interface.
  - E: Error analysis and project summary.
- Included task assignments for team members to streamline presentation flow.
- Introduced a backup plan for live demonstration in case of technical issues.
</commit_message>
<xml_diff>
--- a/课程设计汇报.pptx
+++ b/课程设计汇报.pptx
@@ -5,23 +5,23 @@
     <p:sldMasterId id="2147483648" r:id="rId1"/>
   </p:sldMasterIdLst>
   <p:notesMasterIdLst>
-    <p:notesMasterId r:id="rId15"/>
+    <p:notesMasterId r:id="rId16"/>
   </p:notesMasterIdLst>
   <p:sldIdLst>
     <p:sldId id="256" r:id="rId2"/>
-    <p:sldId id="269" r:id="rId20"/>
-    <p:sldId id="257" r:id="rId3"/>
-    <p:sldId id="258" r:id="rId4"/>
-    <p:sldId id="259" r:id="rId5"/>
-    <p:sldId id="260" r:id="rId6"/>
-    <p:sldId id="261" r:id="rId7"/>
-    <p:sldId id="262" r:id="rId8"/>
-    <p:sldId id="263" r:id="rId9"/>
-    <p:sldId id="264" r:id="rId10"/>
-    <p:sldId id="265" r:id="rId11"/>
-    <p:sldId id="266" r:id="rId12"/>
-    <p:sldId id="267" r:id="rId13"/>
-    <p:sldId id="268" r:id="rId14"/>
+    <p:sldId id="269" r:id="rId3"/>
+    <p:sldId id="257" r:id="rId4"/>
+    <p:sldId id="258" r:id="rId5"/>
+    <p:sldId id="259" r:id="rId6"/>
+    <p:sldId id="260" r:id="rId7"/>
+    <p:sldId id="261" r:id="rId8"/>
+    <p:sldId id="262" r:id="rId9"/>
+    <p:sldId id="263" r:id="rId10"/>
+    <p:sldId id="264" r:id="rId11"/>
+    <p:sldId id="265" r:id="rId12"/>
+    <p:sldId id="266" r:id="rId13"/>
+    <p:sldId id="267" r:id="rId14"/>
+    <p:sldId id="268" r:id="rId15"/>
   </p:sldIdLst>
   <p:sldSz cx="12192000" cy="6858000"/>
   <p:notesSz cx="6858000" cy="12192000"/>
@@ -558,12 +558,6 @@
             <c:idx val="0"/>
             <c:invertIfNegative val="0"/>
             <c:bubble3D val="0"/>
-            <c:spPr>
-              <a:solidFill>
-                <a:srgbClr val="14617C"/>
-              </a:solidFill>
-              <a:effectLst/>
-            </c:spPr>
             <c:extLst>
               <c:ext xmlns:c16="http://schemas.microsoft.com/office/drawing/2014/chart" uri="{C3380CC4-5D6E-409C-BE32-E72D297353CC}">
                 <c16:uniqueId val="{00000001-90A3-4671-980D-1C29823A8039}"/>
@@ -574,12 +568,6 @@
             <c:idx val="1"/>
             <c:invertIfNegative val="0"/>
             <c:bubble3D val="0"/>
-            <c:spPr>
-              <a:solidFill>
-                <a:srgbClr val="14617C"/>
-              </a:solidFill>
-              <a:effectLst/>
-            </c:spPr>
             <c:extLst>
               <c:ext xmlns:c16="http://schemas.microsoft.com/office/drawing/2014/chart" uri="{C3380CC4-5D6E-409C-BE32-E72D297353CC}">
                 <c16:uniqueId val="{00000003-90A3-4671-980D-1C29823A8039}"/>
@@ -590,12 +578,6 @@
             <c:idx val="2"/>
             <c:invertIfNegative val="0"/>
             <c:bubble3D val="0"/>
-            <c:spPr>
-              <a:solidFill>
-                <a:srgbClr val="14617C"/>
-              </a:solidFill>
-              <a:effectLst/>
-            </c:spPr>
             <c:extLst>
               <c:ext xmlns:c16="http://schemas.microsoft.com/office/drawing/2014/chart" uri="{C3380CC4-5D6E-409C-BE32-E72D297353CC}">
                 <c16:uniqueId val="{00000005-90A3-4671-980D-1C29823A8039}"/>
@@ -606,12 +588,6 @@
             <c:idx val="3"/>
             <c:invertIfNegative val="0"/>
             <c:bubble3D val="0"/>
-            <c:spPr>
-              <a:solidFill>
-                <a:srgbClr val="14617C"/>
-              </a:solidFill>
-              <a:effectLst/>
-            </c:spPr>
             <c:extLst>
               <c:ext xmlns:c16="http://schemas.microsoft.com/office/drawing/2014/chart" uri="{C3380CC4-5D6E-409C-BE32-E72D297353CC}">
                 <c16:uniqueId val="{00000007-90A3-4671-980D-1C29823A8039}"/>
@@ -1049,7 +1025,14 @@
           <a:lstStyle/>
           <a:p>
             <a:r>
-              <a:t>各位老师好，我们小组汇报的题目是《基于飞桨的 CIFAR-10 图像分类识别系统》。本项目用飞桨搭建 ResNet18 网络完成十类图像分类，测试集准确率 91.75%，单张推理 3.23 毫秒，配套编写了 46 项自动化测试。下面我们从项目背景、系统设计、系统实现、测试分析和总结五个部分进行汇报。</a:t>
+              <a:t>各位</a:t>
+            </a:r>
+            <a:r>
+              <a:rPr lang="zh-CN" altLang="en-US"/>
+              <a:t>同学、</a:t>
+            </a:r>
+            <a:r>
+              <a:t>老师好，我们小组汇报的题目是《基于飞桨的 CIFAR-10 图像分类识别系统》。本项目用飞桨搭建 ResNet18 网络完成十类图像分类，测试集准确率 91.75%，单张推理 3.23 毫秒，配套编写了 46 项自动化测试。下面我们从项目背景、系统设计、系统实现、测试分析和总结五个部分进行汇报。</a:t>
             </a:r>
           </a:p>
         </p:txBody>
@@ -1135,19 +1118,23 @@
           <a:lstStyle/>
           <a:p>
             <a:r>
-              <a:t>性能方面，单张图片推理耗时 3.23 毫秒，模型权重文件 43 兆。</a:t>
-            </a:r>
-          </a:p>
-          <a:p/>
-          <a:p>
-            <a:r>
-              <a:t>把批次大小从 1 增加到 128，吞吐量从每秒 310 张提升到 4942 张，提升了 16 倍。这说明小批量推理时 GPU 利用率不足，所以如果要做服务化部署，应该采用凑批推理而不是逐张调用。</a:t>
-            </a:r>
-          </a:p>
-          <a:p/>
-          <a:p>
-            <a:r>
-              <a:t>界面这边，模型加载使用了 Streamlit 的资源缓存，整个会话只加载一次，保证页面打开速度。</a:t>
+              <a:t>除了标准测试集，我们还构造了五种扰动测试集，用来模拟真实使用中的脏数据。</a:t>
+            </a:r>
+          </a:p>
+          <a:p>
+            <a:endParaRPr/>
+          </a:p>
+          <a:p>
+            <a:r>
+              <a:t>结果是这样的：随机裁剪平移只下降 0.2 个百分点，几乎无损；中心裁剪和旋转分别下降 3.7 和 6.65 个百分点；而高斯噪声和低分辨率下降非常剧烈，分别掉了 55 和 69 个百分点。</a:t>
+            </a:r>
+          </a:p>
+          <a:p>
+            <a:endParaRPr/>
+          </a:p>
+          <a:p>
+            <a:r>
+              <a:t>这组对比说明两件事。第一，数据增强的收益是可量化的：裁剪平移几乎不掉分，正因为训练时使用了随机裁剪，平移不变性被真正练出来了。第二，噪声和低分辨率是明确的短板，根本原因是训练数据中不存在这类退化，属于典型的分布外问题。针对性的改进是在训练增强中加入噪声和随机旋转。</a:t>
             </a:r>
           </a:p>
         </p:txBody>
@@ -1233,50 +1220,23 @@
           <a:lstStyle/>
           <a:p>
             <a:r>
-              <a:t>这是界面的实际识别结果，三张测试图分别识别为猫、船、马，置信度是 99.99%、100% 和 88.92%。上传图片后，界面会显示 Top-3 类别、置信度柱状图，还可以展开查看全部十类的概率分布。</a:t>
-            </a:r>
-          </a:p>
-          <a:p/>
-          <a:p>
-            <a:r>
-              <a:t>容错方面，模型文件缺失、图片损坏、格式不支持，都会给出中文提示而不是直接崩溃；各种图片模式、位深，甚至原始的像素数组，都会先统一转换成标准 RGB 格式再送入模型。</a:t>
-            </a:r>
-          </a:p>
-          <a:p/>
-          <a:p>
-            <a:r>
-              <a:t>另外，因为训练会覆盖模型文件，我们在训练脚本中加入了自动备份机制，避免误把训练好的模型覆盖成半成品。</a:t>
-            </a:r>
-          </a:p>
-          <a:p/>
-          <a:p>
-            <a:r>
-              <a:t>（周弈恒演示：D 说到「下面由组长为大家现场演示」后把鼠标交给我，我切到浏览器操作——）</a:t>
-            </a:r>
-          </a:p>
-          <a:p>
-            <a:r>
-              <a:t>界面已经提前启动好了。我现在上传一张船的图片。可以看到系统正确识别为船，置信度 100%；第二名是汽车，但置信度接近 0，说明模型的区分度很高。</a:t>
-            </a:r>
-          </a:p>
-          <a:p>
-            <a:r>
-              <a:t>再上传一张马的图片，识别为马，置信度 88.92%，第二名卡车 5.05%。</a:t>
-            </a:r>
-          </a:p>
-          <a:p>
-            <a:r>
-              <a:t>最后展开全部十类的概率分布，可以看到模型对每个类别都给出了完整概率。</a:t>
-            </a:r>
-          </a:p>
-          <a:p>
-            <a:r>
-              <a:t>最后上传一张噪声图片——系统不会硬给一个类别，而是提示置信度异常，把它归为「其他」。因为我们加了开集识别：置信度或 logit 低于阈值就判定图片不属于这十个类别。</a:t>
-            </a:r>
-          </a:p>
-          <a:p>
-            <a:r>
-              <a:t>演示到此，下面请 铁承宇 做工程复盘与总结。</a:t>
+              <a:t>性能方面，单张图片推理耗时 3.23 毫秒，模型权重文件 43 兆。</a:t>
+            </a:r>
+          </a:p>
+          <a:p>
+            <a:endParaRPr/>
+          </a:p>
+          <a:p>
+            <a:r>
+              <a:t>把批次大小从 1 增加到 128，吞吐量从每秒 310 张提升到 4942 张，提升了 16 倍。这说明小批量推理时 GPU 利用率不足，所以如果要做服务化部署，应该采用凑批推理而不是逐张调用。</a:t>
+            </a:r>
+          </a:p>
+          <a:p>
+            <a:endParaRPr/>
+          </a:p>
+          <a:p>
+            <a:r>
+              <a:t>界面这边，模型加载使用了 Streamlit 的资源缓存，整个会话只加载一次，保证页面打开速度。</a:t>
             </a:r>
           </a:p>
         </p:txBody>
@@ -1362,19 +1322,56 @@
           <a:lstStyle/>
           <a:p>
             <a:r>
-              <a:t>开发过程中我们遇到并解决了两个比较典型的故障。</a:t>
-            </a:r>
-          </a:p>
-          <a:p/>
-          <a:p>
-            <a:r>
-              <a:t>第一个是命令行能正常识别，但网页上传任何图片都报 uint8 错误。我们拿到完整错误堆栈后定位到，飞桨在静态图模式下会拒绝 uint8 类型的数组，而图像转换环节内部恰好把原始像素的 uint8 数组交给了飞桨。修复方式是自己实现图像到张量的转换，绕开这个环节，同时在程序入口自动把运行模式切回动态图模式。</a:t>
-            </a:r>
-          </a:p>
-          <a:p/>
-          <a:p>
-            <a:r>
-              <a:t>第二个是上传第一张图片正常，之后上传任何图片都返回同一个结果。原因是推理函数被加了缓存，而我们把图片参数命名为下划线开头，Streamlit 会忽略下划线开头的参数参与缓存键计算，导致缓存键恒定不变。修复方式是去掉这个缓存，并补充了一个界面端到端测试，连续上传三张不同图片，断言结果各不相同。</a:t>
+              <a:t>这是界面的实际识别结果，三张测试图分别识别为猫、船、马，置信度是 99.99%、100% 和 88.92%。上传图片后，界面会显示 Top-3 类别、置信度柱状图，还可以展开查看全部十类的概率分布。</a:t>
+            </a:r>
+          </a:p>
+          <a:p>
+            <a:endParaRPr/>
+          </a:p>
+          <a:p>
+            <a:r>
+              <a:t>容错方面，模型文件缺失、图片损坏、格式不支持，都会给出中文提示而不是直接崩溃；各种图片模式、位深，甚至原始的像素数组，都会先统一转换成标准 RGB 格式再送入模型。</a:t>
+            </a:r>
+          </a:p>
+          <a:p>
+            <a:endParaRPr/>
+          </a:p>
+          <a:p>
+            <a:r>
+              <a:t>另外，因为训练会覆盖模型文件，我们在训练脚本中加入了自动备份机制，避免误把训练好的模型覆盖成半成品。</a:t>
+            </a:r>
+          </a:p>
+          <a:p>
+            <a:endParaRPr/>
+          </a:p>
+          <a:p>
+            <a:r>
+              <a:t>（现场演示由组长操作：周弈恒说到「下面由组长为大家现场演示」后，把鼠标交给组长靳毅航，由组长切到浏览器操作——）</a:t>
+            </a:r>
+          </a:p>
+          <a:p>
+            <a:r>
+              <a:t>界面已经提前启动好了。我现在上传一张船的图片。可以看到系统正确识别为船，置信度 100%；第二名是汽车，但置信度接近 0，说明模型的区分度很高。</a:t>
+            </a:r>
+          </a:p>
+          <a:p>
+            <a:r>
+              <a:t>再上传一张马的图片，识别为马，置信度 88.92%，第二名卡车 5.05%。</a:t>
+            </a:r>
+          </a:p>
+          <a:p>
+            <a:r>
+              <a:t>最后展开全部十类的概率分布，可以看到模型对每个类别都给出了完整概率。</a:t>
+            </a:r>
+          </a:p>
+          <a:p>
+            <a:r>
+              <a:t>最后上传一张噪声图片——系统不会硬给一个类别，而是提示置信度异常，把它归为「其他」。因为我们加了开集识别：置信度或 logit 低于阈值就判定图片不属于这十个类别。</a:t>
+            </a:r>
+          </a:p>
+          <a:p>
+            <a:r>
+              <a:t>演示到此，下面请 铁承宇 做工程复盘与总结。</a:t>
             </a:r>
           </a:p>
         </p:txBody>
@@ -1460,19 +1457,23 @@
           <a:lstStyle/>
           <a:p>
             <a:r>
-              <a:t>最后总结一下。本项目完整跑通了从数据管理、模型搭建、训练调优、多维评估，到网页部署和文档编写的全流程；测试集准确率 91.75%，宏平均 F1 为 0.9174；测试方面有 46 项自动化测试，其中包含界面端到端测试；分析上不仅给出了指标，还量化了数据增强的收益，并定位了噪声与低分辨率这两个短板。</a:t>
-            </a:r>
-          </a:p>
-          <a:p/>
-          <a:p>
-            <a:r>
-              <a:t>下一步的改进方向有三个：一是引入 Mixup、AutoAugment 等更强的增强手段，或者升级到 ResNet34，进一步提升精度；二是在训练增强中加入噪声与随机旋转，针对性补齐鲁棒性短板；三是扩展批量推理和 ONNX 导出，便于实际部署。</a:t>
-            </a:r>
-          </a:p>
-          <a:p/>
-          <a:p>
-            <a:r>
-              <a:t>我们的汇报到此结束，请各位老师批评指正，谢谢。</a:t>
+              <a:t>开发过程中我们遇到并解决了两个比较典型的故障。</a:t>
+            </a:r>
+          </a:p>
+          <a:p>
+            <a:endParaRPr/>
+          </a:p>
+          <a:p>
+            <a:r>
+              <a:t>第一个是命令行能正常识别，但网页上传任何图片都报 uint8 错误。我们拿到完整错误堆栈后定位到，飞桨在静态图模式下会拒绝 uint8 类型的数组，而图像转换环节内部恰好把原始像素的 uint8 数组交给了飞桨。修复方式是自己实现图像到张量的转换，绕开这个环节，同时在程序入口自动把运行模式切回动态图模式。</a:t>
+            </a:r>
+          </a:p>
+          <a:p>
+            <a:endParaRPr/>
+          </a:p>
+          <a:p>
+            <a:r>
+              <a:t>第二个是上传第一张图片正常，之后上传任何图片都返回同一个结果。原因是推理函数被加了缓存，而我们把图片参数命名为下划线开头，Streamlit 会忽略下划线开头的参数参与缓存键计算，导致缓存键恒定不变。修复方式是去掉这个缓存，并补充了一个界面端到端测试，连续上传三张不同图片，断言结果各不相同。</a:t>
             </a:r>
           </a:p>
         </p:txBody>
@@ -1514,7 +1515,7 @@
 </file>
 
 <file path=ppt/notesSlides/notesSlide14.xml><?xml version="1.0" encoding="utf-8"?>
-<p:notes xmlns:a="http://schemas.openxmlformats.org/drawingml/2006/main" xmlns:p="http://schemas.openxmlformats.org/presentationml/2006/main" xmlns:r="http://schemas.openxmlformats.org/officeDocument/2006/relationships">
+<p:notes xmlns:a="http://schemas.openxmlformats.org/drawingml/2006/main" xmlns:r="http://schemas.openxmlformats.org/officeDocument/2006/relationships" xmlns:p="http://schemas.openxmlformats.org/presentationml/2006/main">
   <p:cSld>
     <p:spTree>
       <p:nvGrpSpPr>
@@ -1532,6 +1533,18 @@
       </p:grpSpPr>
       <p:sp>
         <p:nvSpPr>
+          <p:cNvPr id="2" name="Slide Image Placeholder 1"/>
+          <p:cNvSpPr>
+            <a:spLocks noGrp="1" noRot="1" noChangeAspect="1"/>
+          </p:cNvSpPr>
+          <p:nvPr>
+            <p:ph type="sldImg"/>
+          </p:nvPr>
+        </p:nvSpPr>
+        <p:spPr/>
+      </p:sp>
+      <p:sp>
+        <p:nvSpPr>
           <p:cNvPr id="3" name="Notes Placeholder 2"/>
           <p:cNvSpPr>
             <a:spLocks noGrp="1"/>
@@ -1546,12 +1559,56 @@
           <a:lstStyle/>
           <a:p>
             <a:r>
-              <a:t>我们小组共五个人。我负责需求分析、系统架构和模型实现；李迎奥负责数据集调研和增强实验记录；王锦负责测试用图和评估图表整理；周弈恒负责界面测试和说明书校对；铁承宇负责技术文档和测试执行。下面先从项目背景讲起。</a:t>
-            </a:r>
+              <a:t>最后总结一下。本项目完整跑通了从数据管理、模型搭建、训练调优、多维评估，到网页部署和文档编写的全流程；测试集准确率 91.75%，宏平均 F1 为 0.9174；测试方面有 46 项自动化测试，其中包含界面端到端测试；分析上不仅给出了指标，还量化了数据增强的收益，并定位了噪声与低分辨率这两个短板。</a:t>
+            </a:r>
+          </a:p>
+          <a:p>
+            <a:endParaRPr/>
+          </a:p>
+          <a:p>
+            <a:r>
+              <a:t>下一步的改进方向有三个：一是引入 Mixup、AutoAugment 等更强的增强手段，或者升级到 ResNet34，进一步提升精度；二是在训练增强中加入噪声与随机旋转，针对性补齐鲁棒性短板；三是扩展批量推理和 ONNX 导出，便于实际部署。</a:t>
+            </a:r>
+          </a:p>
+          <a:p>
+            <a:endParaRPr/>
+          </a:p>
+          <a:p>
+            <a:r>
+              <a:t>我们的汇报到此结束，请各位老师批评指正，谢谢。</a:t>
+            </a:r>
+          </a:p>
+        </p:txBody>
+      </p:sp>
+      <p:sp>
+        <p:nvSpPr>
+          <p:cNvPr id="4" name="Slide Number Placeholder 3"/>
+          <p:cNvSpPr>
+            <a:spLocks noGrp="1"/>
+          </p:cNvSpPr>
+          <p:nvPr>
+            <p:ph type="sldNum" sz="quarter" idx="10"/>
+          </p:nvPr>
+        </p:nvSpPr>
+        <p:spPr/>
+        <p:txBody>
+          <a:bodyPr/>
+          <a:lstStyle/>
+          <a:p>
+            <a:fld id="{F7021451-1387-4CA6-816F-3879F97B5CBC}" type="slidenum">
+              <a:rPr lang="en-US"/>
+              <a:t>14</a:t>
+            </a:fld>
+            <a:endParaRPr lang="en-US"/>
           </a:p>
         </p:txBody>
       </p:sp>
     </p:spTree>
+    <p:extLst>
+      <p:ext uri="{BB962C8B-B14F-4D97-AF65-F5344CB8AC3E}">
+        <p14:creationId xmlns:p14="http://schemas.microsoft.com/office/powerpoint/2010/main" val="1024086991"/>
+      </p:ext>
+    </p:extLst>
   </p:cSld>
   <p:clrMapOvr>
     <a:masterClrMapping/>
@@ -1578,18 +1635,6 @@
       </p:grpSpPr>
       <p:sp>
         <p:nvSpPr>
-          <p:cNvPr id="2" name="Slide Image Placeholder 1"/>
-          <p:cNvSpPr>
-            <a:spLocks noGrp="1" noRot="1" noChangeAspect="1"/>
-          </p:cNvSpPr>
-          <p:nvPr>
-            <p:ph type="sldImg"/>
-          </p:nvPr>
-        </p:nvSpPr>
-        <p:spPr/>
-      </p:sp>
-      <p:sp>
-        <p:nvSpPr>
           <p:cNvPr id="3" name="Notes Placeholder 2"/>
           <p:cNvSpPr>
             <a:spLocks noGrp="1"/>
@@ -1604,13 +1649,7 @@
           <a:lstStyle/>
           <a:p>
             <a:r>
-              <a:t>图像分类是计算机视觉的基础任务。我们选择 CIFAR-10 数据集，它包含六万张 32×32 的彩色图像、共十个类别，分辨率低、类间差异小，既能完整体验从数据到部署的全流程，又能在普通显卡上快速实验。</a:t>
-            </a:r>
-          </a:p>
-          <a:p/>
-          <a:p>
-            <a:r>
-              <a:t>围绕课程要求，我们为项目设定了三个目标：第一是精度达标，测试集准确率超过 90%，并给出逐类指标；第二是可交互，上传图片就能得到 Top-3 类别与置信度；第三是可交付，结构模块化、有测试、有文档，能直接交给别人运行。</a:t>
+              <a:t>我们小组共五个人。我负责需求分析、系统架构和模型实现；李迎奥负责数据集调研和增强实验记录；王锦负责测试用图和评估图表整理；周弈恒负责界面测试和说明书校对；铁承宇负责技术文档和测试执行。下面先从项目背景讲起。</a:t>
             </a:r>
           </a:p>
         </p:txBody>
@@ -1639,11 +1678,6 @@
         </p:txBody>
       </p:sp>
     </p:spTree>
-    <p:extLst>
-      <p:ext uri="{BB962C8B-B14F-4D97-AF65-F5344CB8AC3E}">
-        <p14:creationId xmlns:p14="http://schemas.microsoft.com/office/powerpoint/2010/main" val="1024086991"/>
-      </p:ext>
-    </p:extLst>
   </p:cSld>
   <p:clrMapOvr>
     <a:masterClrMapping/>
@@ -1696,13 +1730,15 @@
           <a:lstStyle/>
           <a:p>
             <a:r>
-              <a:t>系统分为四层。用户交互层是 Streamlit 网页和命令行推理；业务逻辑层负责训练、评估、鲁棒性测试和耗时分析；核心组件层是模型、数据与工具模块；最下面是集中管理全部超参数和路径的配置文件以及运行产物。</a:t>
-            </a:r>
-          </a:p>
-          <a:p/>
-          <a:p>
-            <a:r>
-              <a:t>设计上我们特别做了一点：命令行和网页共用同一个推理函数，训练和评估共用同一套指标与模型加载逻辑，这样不同入口的行为完全一致，不会出现两边结果不一致的情况。</a:t>
+              <a:t>图像分类是计算机视觉的基础任务。我们选择 CIFAR-10 数据集，它包含六万张 32×32 的彩色图像、共十个类别，分辨率低、类间差异小，既能完整体验从数据到部署的全流程，又能在普通显卡上快速实验。</a:t>
+            </a:r>
+          </a:p>
+          <a:p>
+            <a:endParaRPr/>
+          </a:p>
+          <a:p>
+            <a:r>
+              <a:t>围绕课程要求，我们为项目设定了三个目标：第一是精度达标，测试集准确率超过 90%，并给出逐类指标；第二是可交互，上传图片就能得到 Top-3 类别与置信度；第三是可交付，结构模块化、有测试、有文档，能直接交给别人运行。</a:t>
             </a:r>
           </a:p>
         </p:txBody>
@@ -1788,13 +1824,15 @@
           <a:lstStyle/>
           <a:p>
             <a:r>
-              <a:t>数据处理上，五万张官方训练图按固定随机种子划分为四万五千张训练集和五千张验证集，一万张测试集全程不参与训练。使用固定种子的好处是，助教在自己机器上复现时，数据划分与我们这里完全一致。</a:t>
-            </a:r>
-          </a:p>
-          <a:p/>
-          <a:p>
-            <a:r>
-              <a:t>训练阶段用了两种数据增强：随机裁剪和随机水平翻转，用来提升平移不变性、抑制过拟合。验证、测试和推理只做标准化，保证评估公平。数据在首次运行时会自动下载，并做 MD5 校验，文件损坏会自动重新下载。</a:t>
+              <a:t>系统分为四层。用户交互层是 Streamlit 网页和命令行推理；业务逻辑层负责训练、评估、鲁棒性测试和耗时分析；核心组件层是模型、数据与工具模块；最下面是集中管理全部超参数和路径的配置文件以及运行产物。</a:t>
+            </a:r>
+          </a:p>
+          <a:p>
+            <a:endParaRPr/>
+          </a:p>
+          <a:p>
+            <a:r>
+              <a:t>设计上我们特别做了一点：命令行和网页共用同一个推理函数，训练和评估共用同一套指标与模型加载逻辑，这样不同入口的行为完全一致，不会出现两边结果不一致的情况。</a:t>
             </a:r>
           </a:p>
         </p:txBody>
@@ -1880,19 +1918,15 @@
           <a:lstStyle/>
           <a:p>
             <a:r>
-              <a:t>模型我们选择 ResNet18，因为它在精度和计算量之间平衡最好，同时也是课程教材第五章的案例。</a:t>
-            </a:r>
-          </a:p>
-          <a:p/>
-          <a:p>
-            <a:r>
-              <a:t>标准 ResNet18 是为 224×224 输入设计的，直接用在 32×32 小图上会导致特征图被过度下采样。所以我们做了三处适配：首层卷积改为 3×3 小步长，去掉第一个最大池化层，末端保留全局平均池化。这样各阶段特征图依次是 32、32、16、8、4 的分辨率，最后接全连接层输出十个类别，整个网络共 1117 万参数。</a:t>
-            </a:r>
-          </a:p>
-          <a:p/>
-          <a:p>
-            <a:r>
-              <a:t>左侧是残差块的结构示意。跳跃连接让梯度可以抄近路直接回传，避免深层网络退化，这是 ResNet 能够稳定收敛的关键。</a:t>
+              <a:t>数据处理上，五万张官方训练图按固定随机种子划分为四万五千张训练集和五千张验证集，一万张测试集全程不参与训练。使用固定种子的好处是，助教在自己机器上复现时，数据划分与我们这里完全一致。</a:t>
+            </a:r>
+          </a:p>
+          <a:p>
+            <a:endParaRPr/>
+          </a:p>
+          <a:p>
+            <a:r>
+              <a:t>训练阶段用了两种数据增强：随机裁剪和随机水平翻转，用来提升平移不变性、抑制过拟合。验证、测试和推理只做标准化，保证评估公平。数据在首次运行时会自动下载，并做 MD5 校验，文件损坏会自动重新下载。</a:t>
             </a:r>
           </a:p>
         </p:txBody>
@@ -1978,19 +2012,23 @@
           <a:lstStyle/>
           <a:p>
             <a:r>
-              <a:t>训练使用交叉熵损失，Adam 优化器，初始学习率千分之一，权重衰减五乘十的负四次方。学习率采用阶梯衰减，每二十轮降为原来的十分之一。</a:t>
-            </a:r>
-          </a:p>
-          <a:p/>
-          <a:p>
-            <a:r>
-              <a:t>从训练曲线上可以看到两个关键现象。第一，第二十轮学习率下降之后，验证准确率出现了明显的台阶式跳升。第二，第三十轮之后，训练损失还在继续下降，但验证损失开始回升，这是典型的过拟合信号。</a:t>
-            </a:r>
-          </a:p>
-          <a:p/>
-          <a:p>
-            <a:r>
-              <a:t>因此我们设置了早停机制，验证准确率连续十轮不提升就停止训练，最终在第四十轮触发早停，最佳模型取自第三十轮，验证准确率 92.56%。整个训练在 RTX 5060 显卡上约耗时四十八分钟。</a:t>
+              <a:t>模型我们选择 ResNet18，因为它在精度和计算量之间平衡最好，同时也是课程教材第五章的案例。</a:t>
+            </a:r>
+          </a:p>
+          <a:p>
+            <a:endParaRPr/>
+          </a:p>
+          <a:p>
+            <a:r>
+              <a:t>标准 ResNet18 是为 224×224 输入设计的，直接用在 32×32 小图上会导致特征图被过度下采样。所以我们做了三处适配：首层卷积改为 3×3 小步长，去掉第一个最大池化层，末端保留全局平均池化。这样各阶段特征图依次是 32、32、16、8、4 的分辨率，最后接全连接层输出十个类别，整个网络共 1117 万参数。</a:t>
+            </a:r>
+          </a:p>
+          <a:p>
+            <a:endParaRPr/>
+          </a:p>
+          <a:p>
+            <a:r>
+              <a:t>左侧是残差块的结构示意。跳跃连接让梯度可以抄近路直接回传，避免深层网络退化，这是 ResNet 能够稳定收敛的关键。</a:t>
             </a:r>
           </a:p>
         </p:txBody>
@@ -2076,13 +2114,23 @@
           <a:lstStyle/>
           <a:p>
             <a:r>
-              <a:t>在完全没有参与训练的一万张测试集上，准确率达到 91.75%，宏平均 F1 为 0.9174，十个类别的表现比较均衡。</a:t>
-            </a:r>
-          </a:p>
-          <a:p/>
-          <a:p>
-            <a:r>
-              <a:t>从逐类 F1 看，汽车最高，达到 0.959；猫最低，0.828。原因是猫的姿态和毛色变化很大，而且与狗高度相似。该结构在公开结果中的最好水平大约是 93% 到 94%，我们这里还有一点差距，改进方向后面会说明。</a:t>
+              <a:t>训练使用交叉熵损失，Adam 优化器，初始学习率千分之一，权重衰减五乘十的负四次方。学习率采用阶梯衰减，每二十轮降为原来的十分之一。</a:t>
+            </a:r>
+          </a:p>
+          <a:p>
+            <a:endParaRPr/>
+          </a:p>
+          <a:p>
+            <a:r>
+              <a:t>从训练曲线上可以看到两个关键现象。第一，第二十轮学习率下降之后，验证准确率出现了明显的台阶式跳升。第二，第三十轮之后，训练损失还在继续下降，但验证损失开始回升，这是典型的过拟合信号。</a:t>
+            </a:r>
+          </a:p>
+          <a:p>
+            <a:endParaRPr/>
+          </a:p>
+          <a:p>
+            <a:r>
+              <a:t>因此我们设置了早停机制，验证准确率连续十轮不提升就停止训练，最终在第四十轮触发早停，最佳模型取自第三十轮，验证准确率 92.56%。整个训练在 RTX 5060 显卡上约耗时四十八分钟。</a:t>
             </a:r>
           </a:p>
         </p:txBody>
@@ -2168,13 +2216,15 @@
           <a:lstStyle/>
           <a:p>
             <a:r>
-              <a:t>为了看清模型究竟错在哪里，我们计算了混淆矩阵。对角线是各类的召回率，汽车、船和青蛙都在 0.95 左右，表现最好。</a:t>
-            </a:r>
-          </a:p>
-          <a:p/>
-          <a:p>
-            <a:r>
-              <a:t>非对角线上的错误集中在语义相近的类别之间：狗被识别成猫 92 次，猫被识别成狗 63 次，鸟被识别成飞机 33 次。这说明模型的错误不是随机的，而是集中在形态相似的类别上，与人的直觉一致。改进方向是引入更强的数据增强，比如 Mixup，或者换用更深的网络。</a:t>
+              <a:t>在完全没有参与训练的一万张测试集上，准确率达到 91.75%，宏平均 F1 为 0.9174，十个类别的表现比较均衡。</a:t>
+            </a:r>
+          </a:p>
+          <a:p>
+            <a:endParaRPr/>
+          </a:p>
+          <a:p>
+            <a:r>
+              <a:t>从逐类 F1 看，汽车最高，达到 0.959；猫最低，0.828。原因是猫的姿态和毛色变化很大，而且与狗高度相似。该结构在公开结果中的最好水平大约是 93% 到 94%，我们这里还有一点差距，改进方向后面会说明。</a:t>
             </a:r>
           </a:p>
         </p:txBody>
@@ -2260,19 +2310,15 @@
           <a:lstStyle/>
           <a:p>
             <a:r>
-              <a:t>除了标准测试集，我们还构造了五种扰动测试集，用来模拟真实使用中的脏数据。</a:t>
-            </a:r>
-          </a:p>
-          <a:p/>
-          <a:p>
-            <a:r>
-              <a:t>结果是这样的：随机裁剪平移只下降 0.2 个百分点，几乎无损；中心裁剪和旋转分别下降 3.7 和 6.65 个百分点；而高斯噪声和低分辨率下降非常剧烈，分别掉了 55 和 69 个百分点。</a:t>
-            </a:r>
-          </a:p>
-          <a:p/>
-          <a:p>
-            <a:r>
-              <a:t>这组对比说明两件事。第一，数据增强的收益是可量化的：裁剪平移几乎不掉分，正因为训练时使用了随机裁剪，平移不变性被真正练出来了。第二，噪声和低分辨率是明确的短板，根本原因是训练数据中不存在这类退化，属于典型的分布外问题。针对性的改进是在训练增强中加入噪声和随机旋转。</a:t>
+              <a:t>为了看清模型究竟错在哪里，我们计算了混淆矩阵。对角线是各类的召回率，汽车、船和青蛙都在 0.95 左右，表现最好。</a:t>
+            </a:r>
+          </a:p>
+          <a:p>
+            <a:endParaRPr/>
+          </a:p>
+          <a:p>
+            <a:r>
+              <a:t>非对角线上的错误集中在语义相近的类别之间：狗被识别成猫 92 次，猫被识别成狗 63 次，鸟被识别成飞机 33 次。这说明模型的错误不是随机的，而是集中在形态相似的类别上，与人的直觉一致。改进方向是引入更强的数据增强，比如 Mixup，或者换用更深的网络。</a:t>
             </a:r>
           </a:p>
         </p:txBody>
@@ -3057,7 +3103,7 @@
                 <a:ea typeface="微软雅黑" pitchFamily="34" charset="-122"/>
                 <a:cs typeface="微软雅黑" pitchFamily="34" charset="-120"/>
               </a:rPr>
-              <a:t>汇报人：</a:t>
+              <a:t>小组成员：</a:t>
             </a:r>
             <a:r>
               <a:rPr lang="zh-CN" altLang="en-US" sz="1300">
@@ -3068,29 +3114,7 @@
                 <a:ea typeface="微软雅黑" pitchFamily="34" charset="-122"/>
                 <a:cs typeface="微软雅黑" pitchFamily="34" charset="-120"/>
               </a:rPr>
-              <a:t>靳毅航</a:t>
-            </a:r>
-            <a:r>
-              <a:rPr lang="en-US" sz="1300">
-                <a:solidFill>
-                  <a:srgbClr val="9DB9C4"/>
-                </a:solidFill>
-                <a:latin typeface="微软雅黑" pitchFamily="34" charset="0"/>
-                <a:ea typeface="微软雅黑" pitchFamily="34" charset="-122"/>
-                <a:cs typeface="微软雅黑" pitchFamily="34" charset="-120"/>
-              </a:rPr>
-              <a:t>　　学号：</a:t>
-            </a:r>
-            <a:r>
-              <a:rPr lang="en-US" altLang="zh-CN" sz="1300">
-                <a:solidFill>
-                  <a:srgbClr val="9DB9C4"/>
-                </a:solidFill>
-                <a:latin typeface="微软雅黑" pitchFamily="34" charset="0"/>
-                <a:ea typeface="微软雅黑" pitchFamily="34" charset="-122"/>
-                <a:cs typeface="微软雅黑" pitchFamily="34" charset="-120"/>
-              </a:rPr>
-              <a:t>02025410</a:t>
+              <a:t>靳毅航　李迎奥　王锦　周弈恒　铁承宇</a:t>
             </a:r>
             <a:r>
               <a:rPr lang="en-US" sz="1300">
@@ -6904,7 +6928,7 @@
                 <a:ea typeface="微软雅黑" pitchFamily="34" charset="-122"/>
                 <a:cs typeface="微软雅黑" pitchFamily="34" charset="-120"/>
               </a:rPr>
-              <a:t>另记录 13 例（路径、维度、显存、模型加载、中文乱码等），完整清单见 docs/technical_doc.md 第 6 节</a:t>
+              <a:t>另记录 14 例（路径、维度、显存、模型加载、中文乱码等），完整清单见 docs/technical_doc.md 第 6 节</a:t>
             </a:r>
             <a:endParaRPr lang="en-US" sz="1100" dirty="0"/>
           </a:p>
@@ -7499,7 +7523,7 @@
 </file>
 
 <file path=ppt/slides/slide2.xml><?xml version="1.0" encoding="utf-8"?>
-<p:sld xmlns:a="http://schemas.openxmlformats.org/drawingml/2006/main" xmlns:p="http://schemas.openxmlformats.org/presentationml/2006/main" xmlns:r="http://schemas.openxmlformats.org/officeDocument/2006/relationships">
+<p:sld xmlns:a="http://schemas.openxmlformats.org/drawingml/2006/main" xmlns:r="http://schemas.openxmlformats.org/officeDocument/2006/relationships" xmlns:p="http://schemas.openxmlformats.org/presentationml/2006/main">
   <p:cSld>
     <p:bg>
       <p:bgPr>
@@ -7515,7 +7539,14 @@
         <p:cNvGrpSpPr/>
         <p:nvPr/>
       </p:nvGrpSpPr>
-      <p:grpSpPr/>
+      <p:grpSpPr>
+        <a:xfrm>
+          <a:off x="0" y="0"/>
+          <a:ext cx="0" cy="0"/>
+          <a:chOff x="0" y="0"/>
+          <a:chExt cx="0" cy="0"/>
+        </a:xfrm>
+      </p:grpSpPr>
       <p:sp>
         <p:nvSpPr>
           <p:cNvPr id="2" name="TextBox 1"/>
@@ -7533,7 +7564,7 @@
           <a:noFill/>
         </p:spPr>
         <p:txBody>
-          <a:bodyPr wrap="square" anchor="ctr" lIns="0" rIns="0" tIns="0" bIns="0">
+          <a:bodyPr wrap="square" lIns="0" tIns="0" rIns="0" bIns="0" anchor="ctr">
             <a:spAutoFit/>
           </a:bodyPr>
           <a:lstStyle/>
@@ -7570,7 +7601,7 @@
           <a:noFill/>
         </p:spPr>
         <p:txBody>
-          <a:bodyPr wrap="square" anchor="ctr" lIns="0" rIns="0" tIns="0" bIns="0">
+          <a:bodyPr wrap="square" lIns="0" tIns="0" rIns="0" bIns="0" anchor="ctr">
             <a:spAutoFit/>
           </a:bodyPr>
           <a:lstStyle/>
@@ -7635,6 +7666,7 @@
           <a:lstStyle/>
           <a:p>
             <a:pPr algn="ctr"/>
+            <a:endParaRPr/>
           </a:p>
         </p:txBody>
       </p:sp>
@@ -7679,7 +7711,7 @@
           </a:fontRef>
         </p:style>
         <p:txBody>
-          <a:bodyPr rtlCol="0" anchor="ctr" wrap="square" lIns="0" rIns="0" tIns="0" bIns="0"/>
+          <a:bodyPr wrap="square" lIns="0" tIns="0" rIns="0" bIns="0" rtlCol="0" anchor="ctr"/>
           <a:lstStyle/>
           <a:p>
             <a:pPr algn="ctr"/>
@@ -7728,7 +7760,7 @@
           <a:noFill/>
         </p:spPr>
         <p:txBody>
-          <a:bodyPr wrap="square" anchor="ctr" lIns="0" rIns="0" tIns="0" bIns="0">
+          <a:bodyPr wrap="square" lIns="0" tIns="0" rIns="0" bIns="0" anchor="ctr">
             <a:spAutoFit/>
           </a:bodyPr>
           <a:lstStyle/>
@@ -7793,6 +7825,7 @@
           <a:lstStyle/>
           <a:p>
             <a:pPr algn="ctr"/>
+            <a:endParaRPr/>
           </a:p>
         </p:txBody>
       </p:sp>
@@ -7837,7 +7870,7 @@
           </a:fontRef>
         </p:style>
         <p:txBody>
-          <a:bodyPr rtlCol="0" anchor="ctr" wrap="square" lIns="0" rIns="0" tIns="0" bIns="0"/>
+          <a:bodyPr wrap="square" lIns="0" tIns="0" rIns="0" bIns="0" rtlCol="0" anchor="ctr"/>
           <a:lstStyle/>
           <a:p>
             <a:pPr algn="ctr"/>
@@ -7886,7 +7919,7 @@
           <a:noFill/>
         </p:spPr>
         <p:txBody>
-          <a:bodyPr wrap="square" anchor="ctr" lIns="0" rIns="0" tIns="0" bIns="0">
+          <a:bodyPr wrap="square" lIns="0" tIns="0" rIns="0" bIns="0" anchor="ctr">
             <a:spAutoFit/>
           </a:bodyPr>
           <a:lstStyle/>
@@ -7951,6 +7984,7 @@
           <a:lstStyle/>
           <a:p>
             <a:pPr algn="ctr"/>
+            <a:endParaRPr/>
           </a:p>
         </p:txBody>
       </p:sp>
@@ -7995,7 +8029,7 @@
           </a:fontRef>
         </p:style>
         <p:txBody>
-          <a:bodyPr rtlCol="0" anchor="ctr" wrap="square" lIns="0" rIns="0" tIns="0" bIns="0"/>
+          <a:bodyPr wrap="square" lIns="0" tIns="0" rIns="0" bIns="0" rtlCol="0" anchor="ctr"/>
           <a:lstStyle/>
           <a:p>
             <a:pPr algn="ctr"/>
@@ -8044,7 +8078,7 @@
           <a:noFill/>
         </p:spPr>
         <p:txBody>
-          <a:bodyPr wrap="square" anchor="ctr" lIns="0" rIns="0" tIns="0" bIns="0">
+          <a:bodyPr wrap="square" lIns="0" tIns="0" rIns="0" bIns="0" anchor="ctr">
             <a:spAutoFit/>
           </a:bodyPr>
           <a:lstStyle/>
@@ -8109,6 +8143,7 @@
           <a:lstStyle/>
           <a:p>
             <a:pPr algn="ctr"/>
+            <a:endParaRPr/>
           </a:p>
         </p:txBody>
       </p:sp>
@@ -8153,7 +8188,7 @@
           </a:fontRef>
         </p:style>
         <p:txBody>
-          <a:bodyPr rtlCol="0" anchor="ctr" wrap="square" lIns="0" rIns="0" tIns="0" bIns="0"/>
+          <a:bodyPr wrap="square" lIns="0" tIns="0" rIns="0" bIns="0" rtlCol="0" anchor="ctr"/>
           <a:lstStyle/>
           <a:p>
             <a:pPr algn="ctr"/>
@@ -8202,7 +8237,7 @@
           <a:noFill/>
         </p:spPr>
         <p:txBody>
-          <a:bodyPr wrap="square" anchor="ctr" lIns="0" rIns="0" tIns="0" bIns="0">
+          <a:bodyPr wrap="square" lIns="0" tIns="0" rIns="0" bIns="0" anchor="ctr">
             <a:spAutoFit/>
           </a:bodyPr>
           <a:lstStyle/>
@@ -8267,6 +8302,7 @@
           <a:lstStyle/>
           <a:p>
             <a:pPr algn="ctr"/>
+            <a:endParaRPr/>
           </a:p>
         </p:txBody>
       </p:sp>
@@ -8311,7 +8347,7 @@
           </a:fontRef>
         </p:style>
         <p:txBody>
-          <a:bodyPr rtlCol="0" anchor="ctr" wrap="square" lIns="0" rIns="0" tIns="0" bIns="0"/>
+          <a:bodyPr wrap="square" lIns="0" tIns="0" rIns="0" bIns="0" rtlCol="0" anchor="ctr"/>
           <a:lstStyle/>
           <a:p>
             <a:pPr algn="ctr"/>
@@ -8360,7 +8396,7 @@
           <a:noFill/>
         </p:spPr>
         <p:txBody>
-          <a:bodyPr wrap="square" anchor="ctr" lIns="0" rIns="0" tIns="0" bIns="0">
+          <a:bodyPr wrap="square" lIns="0" tIns="0" rIns="0" bIns="0" anchor="ctr">
             <a:spAutoFit/>
           </a:bodyPr>
           <a:lstStyle/>
@@ -8397,7 +8433,7 @@
           <a:noFill/>
         </p:spPr>
         <p:txBody>
-          <a:bodyPr wrap="square" anchor="ctr" lIns="0" rIns="0" tIns="0" bIns="0">
+          <a:bodyPr wrap="square" lIns="0" tIns="0" rIns="0" bIns="0" anchor="ctr">
             <a:spAutoFit/>
           </a:bodyPr>
           <a:lstStyle/>
@@ -10062,7 +10098,7 @@
                 <a:ea typeface="微软雅黑" pitchFamily="34" charset="-122"/>
                 <a:cs typeface="微软雅黑" pitchFamily="34" charset="-120"/>
               </a:rPr>
-              <a:t>调用关系详见 docs/technical_doc.md 第 2 节（9 张接口表）与第 8 节（联调说明）</a:t>
+              <a:t>调用关系详见 docs/technical_doc.md 第 2 节（6 张接口表）与第 8 节（联调说明）</a:t>
             </a:r>
             <a:endParaRPr lang="en-US" sz="1100" dirty="0"/>
           </a:p>

</xml_diff>